<commit_message>
Verify Replit workflow and update submission evidence
</commit_message>
<xml_diff>
--- a/submission/DecisionOS_Pitch.pptx
+++ b/submission/DecisionOS_Pitch.pptx
@@ -2,21 +2,21 @@
 <file path=ppt/presentation.xml><?xml version="1.0" encoding="utf-8"?>
 <p:presentation xmlns:p="http://schemas.openxmlformats.org/presentationml/2006/main">
   <p:sldMasterIdLst>
-    <p:sldMasterId xmlns:r="http://schemas.openxmlformats.org/officeDocument/2006/relationships" id="2147483648" r:id="Rfb47fcfc416a46b5"/>
+    <p:sldMasterId xmlns:r="http://schemas.openxmlformats.org/officeDocument/2006/relationships" id="2147483648" r:id="R0a229c1522fc4221"/>
   </p:sldMasterIdLst>
   <p:notesMasterIdLst>
-    <p:notesMasterId xmlns:r="http://schemas.openxmlformats.org/officeDocument/2006/relationships" r:id="R576e5ff9f71643a0"/>
+    <p:notesMasterId xmlns:r="http://schemas.openxmlformats.org/officeDocument/2006/relationships" r:id="R4f0a799daa744f2d"/>
   </p:notesMasterIdLst>
   <p:sldIdLst>
-    <p:sldId xmlns:r="http://schemas.openxmlformats.org/officeDocument/2006/relationships" id="256" r:id="Ra4e137bc97fa4128"/>
-    <p:sldId xmlns:r="http://schemas.openxmlformats.org/officeDocument/2006/relationships" id="257" r:id="R3ae1a3b427304281"/>
-    <p:sldId xmlns:r="http://schemas.openxmlformats.org/officeDocument/2006/relationships" id="258" r:id="R517947722a644400"/>
-    <p:sldId xmlns:r="http://schemas.openxmlformats.org/officeDocument/2006/relationships" id="259" r:id="R83ae0cb29a094bbf"/>
-    <p:sldId xmlns:r="http://schemas.openxmlformats.org/officeDocument/2006/relationships" id="260" r:id="R1448ad9239dc4459"/>
-    <p:sldId xmlns:r="http://schemas.openxmlformats.org/officeDocument/2006/relationships" id="261" r:id="R6f9a4e240c0a469b"/>
-    <p:sldId xmlns:r="http://schemas.openxmlformats.org/officeDocument/2006/relationships" id="262" r:id="R3ec14429f42247a3"/>
-    <p:sldId xmlns:r="http://schemas.openxmlformats.org/officeDocument/2006/relationships" id="263" r:id="Re0ae3eceff184e75"/>
-    <p:sldId xmlns:r="http://schemas.openxmlformats.org/officeDocument/2006/relationships" id="264" r:id="Rcb4f5189733948dd"/>
+    <p:sldId xmlns:r="http://schemas.openxmlformats.org/officeDocument/2006/relationships" id="256" r:id="R34093b77af6544db"/>
+    <p:sldId xmlns:r="http://schemas.openxmlformats.org/officeDocument/2006/relationships" id="257" r:id="R295494a156df4fb3"/>
+    <p:sldId xmlns:r="http://schemas.openxmlformats.org/officeDocument/2006/relationships" id="258" r:id="Rce9bb312a35a4bc7"/>
+    <p:sldId xmlns:r="http://schemas.openxmlformats.org/officeDocument/2006/relationships" id="259" r:id="Reba737883e064f5f"/>
+    <p:sldId xmlns:r="http://schemas.openxmlformats.org/officeDocument/2006/relationships" id="260" r:id="Rd7bf847146454220"/>
+    <p:sldId xmlns:r="http://schemas.openxmlformats.org/officeDocument/2006/relationships" id="261" r:id="Rcd851d8e59b1430a"/>
+    <p:sldId xmlns:r="http://schemas.openxmlformats.org/officeDocument/2006/relationships" id="262" r:id="Rc3bc118cf0aa48d4"/>
+    <p:sldId xmlns:r="http://schemas.openxmlformats.org/officeDocument/2006/relationships" id="263" r:id="Rfc11ba4fc6bb4a11"/>
+    <p:sldId xmlns:r="http://schemas.openxmlformats.org/officeDocument/2006/relationships" id="264" r:id="Reeded75f62964ea4"/>
   </p:sldIdLst>
   <p:sldSz cx="12192000" cy="6858000"/>
   <p:notesSz cx="6858000" cy="9144000"/>
@@ -1010,7 +1010,7 @@
           <a:lstStyle xmlns:a="http://schemas.openxmlformats.org/drawingml/2006/main"/>
           <a:p xmlns:a="http://schemas.openxmlformats.org/drawingml/2006/main">
             <a:r>
-              <a:t>33 backend and 3 component tests passed; typecheck/build passed. Native browser workflow checked. Playwright fails before Chromium launch due to macOS sandbox. No CI pass claim. Replit, team declarations, remote publication pending. User will record video.</a:t>
+              <a:t>In Replit on 23 October 2026: 33 backend tests, 3 component tests, typecheck, build and 4 Playwright tests passed. Browser tests used installed Chromium 152.0.7977.64 after bundled Chromium lacked libglib. Native approval and reload verified. GitHub CI, team declarations and remote publication pending. Workspace: https://replit.com/@jeremyjunxuanta/orbyte-decisionos . User will record video.</a:t>
             </a:r>
           </a:p>
         </p:txBody>
@@ -1057,7 +1057,7 @@
           <p:cNvPr id="3" name="Title">
             <a:extLst xmlns:a="http://schemas.openxmlformats.org/drawingml/2006/main">
               <a:ext uri="{FF2B5EF4-FFF2-40B4-BE49-F238E27FC236}">
-                <a16:creationId xmlns:a16="http://schemas.microsoft.com/office/drawing/2014/main" id="{926AC5BC-5FCD-44B2-851E-A23D86A80804}"/>
+                <a16:creationId xmlns:a16="http://schemas.microsoft.com/office/drawing/2014/main" id="{8E33B002-F848-4ADC-87DF-6467307B6507}"/>
               </a:ext>
             </a:extLst>
           </p:cNvPr>
@@ -1214,7 +1214,7 @@
           <p:cNvPr id="2" name="Subtitle">
             <a:extLst xmlns:a="http://schemas.openxmlformats.org/drawingml/2006/main">
               <a:ext uri="{FF2B5EF4-FFF2-40B4-BE49-F238E27FC236}">
-                <a16:creationId xmlns:a16="http://schemas.microsoft.com/office/drawing/2014/main" id="{F83E5F0A-88BB-404C-AC2B-A16B1556DE8B}"/>
+                <a16:creationId xmlns:a16="http://schemas.microsoft.com/office/drawing/2014/main" id="{53356BF4-E7C7-4A65-A517-25EB62ECF514}"/>
               </a:ext>
             </a:extLst>
           </p:cNvPr>
@@ -1388,7 +1388,7 @@
           <p:cNvPr id="2" name="Section title">
             <a:extLst xmlns:a="http://schemas.openxmlformats.org/drawingml/2006/main">
               <a:ext uri="{FF2B5EF4-FFF2-40B4-BE49-F238E27FC236}">
-                <a16:creationId xmlns:a16="http://schemas.microsoft.com/office/drawing/2014/main" id="{2171EE84-2C9D-458B-BF4E-421F19F8F238}"/>
+                <a16:creationId xmlns:a16="http://schemas.microsoft.com/office/drawing/2014/main" id="{97095D12-E811-4F65-9172-C71EA33446CB}"/>
               </a:ext>
             </a:extLst>
           </p:cNvPr>
@@ -1562,7 +1562,7 @@
           <p:cNvPr id="3" name="Title">
             <a:extLst xmlns:a="http://schemas.openxmlformats.org/drawingml/2006/main">
               <a:ext uri="{FF2B5EF4-FFF2-40B4-BE49-F238E27FC236}">
-                <a16:creationId xmlns:a16="http://schemas.microsoft.com/office/drawing/2014/main" id="{D8056AB6-0614-465E-8447-40B54D73F87E}"/>
+                <a16:creationId xmlns:a16="http://schemas.microsoft.com/office/drawing/2014/main" id="{FF955474-8AB5-4242-89B1-3B5F6909642F}"/>
               </a:ext>
             </a:extLst>
           </p:cNvPr>
@@ -1719,7 +1719,7 @@
           <p:cNvPr id="2" name="Body">
             <a:extLst xmlns:a="http://schemas.openxmlformats.org/drawingml/2006/main">
               <a:ext uri="{FF2B5EF4-FFF2-40B4-BE49-F238E27FC236}">
-                <a16:creationId xmlns:a16="http://schemas.microsoft.com/office/drawing/2014/main" id="{C3F4AAB6-9BF7-4B61-A9C7-CA6BA480FFAB}"/>
+                <a16:creationId xmlns:a16="http://schemas.microsoft.com/office/drawing/2014/main" id="{A9F50BC4-5775-4D91-B5A9-15302682F4BB}"/>
               </a:ext>
             </a:extLst>
           </p:cNvPr>
@@ -1893,7 +1893,7 @@
           <p:cNvPr id="4" name="Title">
             <a:extLst xmlns:a="http://schemas.openxmlformats.org/drawingml/2006/main">
               <a:ext uri="{FF2B5EF4-FFF2-40B4-BE49-F238E27FC236}">
-                <a16:creationId xmlns:a16="http://schemas.microsoft.com/office/drawing/2014/main" id="{422979A8-1F06-48AC-9675-13359C9BABB1}"/>
+                <a16:creationId xmlns:a16="http://schemas.microsoft.com/office/drawing/2014/main" id="{33869890-09C9-4A21-B06E-5B1CE9F2EE41}"/>
               </a:ext>
             </a:extLst>
           </p:cNvPr>
@@ -2050,7 +2050,7 @@
           <p:cNvPr id="2" name="Left column">
             <a:extLst xmlns:a="http://schemas.openxmlformats.org/drawingml/2006/main">
               <a:ext uri="{FF2B5EF4-FFF2-40B4-BE49-F238E27FC236}">
-                <a16:creationId xmlns:a16="http://schemas.microsoft.com/office/drawing/2014/main" id="{1A581B46-879B-4700-AC99-BEA524DD1D0B}"/>
+                <a16:creationId xmlns:a16="http://schemas.microsoft.com/office/drawing/2014/main" id="{1C2718C4-71F3-4782-9459-48B388FEBCB4}"/>
               </a:ext>
             </a:extLst>
           </p:cNvPr>
@@ -2207,7 +2207,7 @@
           <p:cNvPr id="3" name="Right column">
             <a:extLst xmlns:a="http://schemas.openxmlformats.org/drawingml/2006/main">
               <a:ext uri="{FF2B5EF4-FFF2-40B4-BE49-F238E27FC236}">
-                <a16:creationId xmlns:a16="http://schemas.microsoft.com/office/drawing/2014/main" id="{DF338E45-F58A-4ECF-8F75-95B63A61DBBE}"/>
+                <a16:creationId xmlns:a16="http://schemas.microsoft.com/office/drawing/2014/main" id="{402BE27F-2B79-4A05-B467-510669390B2E}"/>
               </a:ext>
             </a:extLst>
           </p:cNvPr>
@@ -2381,7 +2381,7 @@
           <p:cNvPr id="3" name="Title">
             <a:extLst xmlns:a="http://schemas.openxmlformats.org/drawingml/2006/main">
               <a:ext uri="{FF2B5EF4-FFF2-40B4-BE49-F238E27FC236}">
-                <a16:creationId xmlns:a16="http://schemas.microsoft.com/office/drawing/2014/main" id="{9C31EC38-3A07-46C2-BC6A-7C2BF79247A9}"/>
+                <a16:creationId xmlns:a16="http://schemas.microsoft.com/office/drawing/2014/main" id="{ED4EAA5B-C93E-470F-84F5-2077B45AB615}"/>
               </a:ext>
             </a:extLst>
           </p:cNvPr>
@@ -2538,7 +2538,7 @@
           <p:cNvPr id="2" name="Left column">
             <a:extLst xmlns:a="http://schemas.openxmlformats.org/drawingml/2006/main">
               <a:ext uri="{FF2B5EF4-FFF2-40B4-BE49-F238E27FC236}">
-                <a16:creationId xmlns:a16="http://schemas.microsoft.com/office/drawing/2014/main" id="{D3CD2A73-42A5-493A-B68C-43BE3DDB6F78}"/>
+                <a16:creationId xmlns:a16="http://schemas.microsoft.com/office/drawing/2014/main" id="{DC0E1416-5448-475F-94C9-117322E3CAA4}"/>
               </a:ext>
             </a:extLst>
           </p:cNvPr>
@@ -2733,12 +2733,12 @@
   </p:cSld>
   <p:clrMap bg1="lt1" tx1="dk1" bg2="lt2" tx2="dk2" accent1="accent1" accent2="accent2" accent3="accent3" accent4="accent4" accent5="accent5" accent6="accent6" hlink="hlink" folHlink="folHlink"/>
   <p:sldLayoutIdLst>
-    <p:sldLayoutId xmlns:r="http://schemas.openxmlformats.org/officeDocument/2006/relationships" id="2147483649" r:id="Rd3f48f5e40264161"/>
-    <p:sldLayoutId xmlns:r="http://schemas.openxmlformats.org/officeDocument/2006/relationships" id="2147483650" r:id="Rf6259ea3e23a496b"/>
-    <p:sldLayoutId xmlns:r="http://schemas.openxmlformats.org/officeDocument/2006/relationships" id="2147483651" r:id="R3619a110db3d4201"/>
-    <p:sldLayoutId xmlns:r="http://schemas.openxmlformats.org/officeDocument/2006/relationships" id="2147483652" r:id="R426edc550f204ba1"/>
-    <p:sldLayoutId xmlns:r="http://schemas.openxmlformats.org/officeDocument/2006/relationships" id="2147483653" r:id="R5612727da0d64c4f"/>
-    <p:sldLayoutId xmlns:r="http://schemas.openxmlformats.org/officeDocument/2006/relationships" id="2147483654" r:id="R99bc895534494030"/>
+    <p:sldLayoutId xmlns:r="http://schemas.openxmlformats.org/officeDocument/2006/relationships" id="2147483649" r:id="R4135520ab8234b80"/>
+    <p:sldLayoutId xmlns:r="http://schemas.openxmlformats.org/officeDocument/2006/relationships" id="2147483650" r:id="Rfcc3862fa1694ffe"/>
+    <p:sldLayoutId xmlns:r="http://schemas.openxmlformats.org/officeDocument/2006/relationships" id="2147483651" r:id="Ra75bd104b0714b6f"/>
+    <p:sldLayoutId xmlns:r="http://schemas.openxmlformats.org/officeDocument/2006/relationships" id="2147483652" r:id="Rc5621ec7e3424c29"/>
+    <p:sldLayoutId xmlns:r="http://schemas.openxmlformats.org/officeDocument/2006/relationships" id="2147483653" r:id="Rc19859fd47744020"/>
+    <p:sldLayoutId xmlns:r="http://schemas.openxmlformats.org/officeDocument/2006/relationships" id="2147483654" r:id="R9b8bd765364b4f45"/>
   </p:sldLayoutIdLst>
   <p:txStyles>
     <p:titleStyle>
@@ -3289,7 +3289,7 @@
           <p:cNvPr id="4" name="">
             <a:extLst xmlns:a="http://schemas.openxmlformats.org/drawingml/2006/main">
               <a:ext uri="{FF2B5EF4-FFF2-40B4-BE49-F238E27FC236}">
-                <a16:creationId xmlns:a16="http://schemas.microsoft.com/office/drawing/2014/main" id="{4C3DC16A-0BDE-4B0E-BCDE-785008B5F38B}"/>
+                <a16:creationId xmlns:a16="http://schemas.microsoft.com/office/drawing/2014/main" id="{775A5624-A507-4487-BF79-2A02387D7790}"/>
               </a:ext>
             </a:extLst>
           </p:cNvPr>
@@ -3378,7 +3378,7 @@
           <p:cNvPr id="2" name="">
             <a:extLst xmlns:a="http://schemas.openxmlformats.org/drawingml/2006/main">
               <a:ext uri="{FF2B5EF4-FFF2-40B4-BE49-F238E27FC236}">
-                <a16:creationId xmlns:a16="http://schemas.microsoft.com/office/drawing/2014/main" id="{304EBC74-3BF2-4F0A-8051-A320F1BAD14C}"/>
+                <a16:creationId xmlns:a16="http://schemas.microsoft.com/office/drawing/2014/main" id="{4F39CD10-10CA-4767-9472-104236CC72F8}"/>
               </a:ext>
             </a:extLst>
           </p:cNvPr>
@@ -3444,7 +3444,7 @@
           <p:cNvPr id="3" name="">
             <a:extLst xmlns:a="http://schemas.openxmlformats.org/drawingml/2006/main">
               <a:ext uri="{FF2B5EF4-FFF2-40B4-BE49-F238E27FC236}">
-                <a16:creationId xmlns:a16="http://schemas.microsoft.com/office/drawing/2014/main" id="{6CC81D4B-BE61-48E4-B38D-2A0DB4656136}"/>
+                <a16:creationId xmlns:a16="http://schemas.microsoft.com/office/drawing/2014/main" id="{D66C8A08-FB8F-472E-A08F-CC5FD42B5712}"/>
               </a:ext>
             </a:extLst>
           </p:cNvPr>
@@ -3508,7 +3508,7 @@
     </p:spTree>
     <p:extLst>
       <p:ext uri="{BB962C8B-B14F-4D97-AF65-F5344CB8AC3E}">
-        <p14:creationId xmlns:p14="http://schemas.microsoft.com/office/powerpoint/2010/main" val="2057827643"/>
+        <p14:creationId xmlns:p14="http://schemas.microsoft.com/office/powerpoint/2010/main" val="57892804"/>
       </p:ext>
     </p:extLst>
   </p:cSld>
@@ -3539,7 +3539,7 @@
           <p:cNvPr id="7" name="">
             <a:extLst xmlns:a="http://schemas.openxmlformats.org/drawingml/2006/main">
               <a:ext uri="{FF2B5EF4-FFF2-40B4-BE49-F238E27FC236}">
-                <a16:creationId xmlns:a16="http://schemas.microsoft.com/office/drawing/2014/main" id="{D3094557-938E-4FD1-BAFE-877B56292348}"/>
+                <a16:creationId xmlns:a16="http://schemas.microsoft.com/office/drawing/2014/main" id="{51F0A312-DE2C-47B8-9F68-C96672025FFC}"/>
               </a:ext>
             </a:extLst>
           </p:cNvPr>
@@ -3605,7 +3605,7 @@
           <p:cNvPr id="2" name="">
             <a:extLst xmlns:a="http://schemas.openxmlformats.org/drawingml/2006/main">
               <a:ext uri="{FF2B5EF4-FFF2-40B4-BE49-F238E27FC236}">
-                <a16:creationId xmlns:a16="http://schemas.microsoft.com/office/drawing/2014/main" id="{0F520D51-4FC4-478D-8197-29C763A892D8}"/>
+                <a16:creationId xmlns:a16="http://schemas.microsoft.com/office/drawing/2014/main" id="{12854651-D7FF-479F-9448-A9D96E084141}"/>
               </a:ext>
             </a:extLst>
           </p:cNvPr>
@@ -3671,7 +3671,7 @@
           <p:cNvPr id="3" name="">
             <a:extLst xmlns:a="http://schemas.openxmlformats.org/drawingml/2006/main">
               <a:ext uri="{FF2B5EF4-FFF2-40B4-BE49-F238E27FC236}">
-                <a16:creationId xmlns:a16="http://schemas.microsoft.com/office/drawing/2014/main" id="{3D06225A-C865-41F1-958B-01B9DB62F19C}"/>
+                <a16:creationId xmlns:a16="http://schemas.microsoft.com/office/drawing/2014/main" id="{4013B50A-98A3-4CD1-8870-5932B255F7B7}"/>
               </a:ext>
             </a:extLst>
           </p:cNvPr>
@@ -3737,7 +3737,7 @@
           <p:cNvPr id="4" name="">
             <a:extLst xmlns:a="http://schemas.openxmlformats.org/drawingml/2006/main">
               <a:ext uri="{FF2B5EF4-FFF2-40B4-BE49-F238E27FC236}">
-                <a16:creationId xmlns:a16="http://schemas.microsoft.com/office/drawing/2014/main" id="{B7B7505E-D6E2-4ECE-A2FA-010D095556E9}"/>
+                <a16:creationId xmlns:a16="http://schemas.microsoft.com/office/drawing/2014/main" id="{9EE2CF3B-904E-498B-B4EB-F1C70E10BD02}"/>
               </a:ext>
             </a:extLst>
           </p:cNvPr>
@@ -3803,7 +3803,7 @@
           <p:cNvPr id="5" name="">
             <a:extLst xmlns:a="http://schemas.openxmlformats.org/drawingml/2006/main">
               <a:ext uri="{FF2B5EF4-FFF2-40B4-BE49-F238E27FC236}">
-                <a16:creationId xmlns:a16="http://schemas.microsoft.com/office/drawing/2014/main" id="{BE5D4CF9-7C9C-4DC4-9E7D-D25372D17752}"/>
+                <a16:creationId xmlns:a16="http://schemas.microsoft.com/office/drawing/2014/main" id="{96BE9AAA-968D-49FA-A1C7-8C0E2FB684DF}"/>
               </a:ext>
             </a:extLst>
           </p:cNvPr>
@@ -3892,7 +3892,7 @@
           <p:cNvPr id="6" name="">
             <a:extLst xmlns:a="http://schemas.openxmlformats.org/drawingml/2006/main">
               <a:ext uri="{FF2B5EF4-FFF2-40B4-BE49-F238E27FC236}">
-                <a16:creationId xmlns:a16="http://schemas.microsoft.com/office/drawing/2014/main" id="{E64AC47E-5374-46C7-9400-7A9328BE8DCB}"/>
+                <a16:creationId xmlns:a16="http://schemas.microsoft.com/office/drawing/2014/main" id="{8CAB6203-AB7B-4A6C-A6DC-3E23B32B63C9}"/>
               </a:ext>
             </a:extLst>
           </p:cNvPr>
@@ -3902,7 +3902,7 @@
           <p:nvPr/>
         </p:nvPicPr>
         <p:blipFill>
-          <a:blip xmlns:r="http://schemas.openxmlformats.org/officeDocument/2006/relationships" xmlns:a="http://schemas.openxmlformats.org/drawingml/2006/main" r:embed="R21f1cc8ca1104bc2"/>
+          <a:blip xmlns:r="http://schemas.openxmlformats.org/officeDocument/2006/relationships" xmlns:a="http://schemas.openxmlformats.org/drawingml/2006/main" r:embed="R07682e4e1bd24206"/>
           <a:stretch xmlns:a="http://schemas.openxmlformats.org/drawingml/2006/main"/>
         </p:blipFill>
         <p:spPr>
@@ -3918,7 +3918,7 @@
     </p:spTree>
     <p:extLst>
       <p:ext uri="{BB962C8B-B14F-4D97-AF65-F5344CB8AC3E}">
-        <p14:creationId xmlns:p14="http://schemas.microsoft.com/office/powerpoint/2010/main" val="137058228"/>
+        <p14:creationId xmlns:p14="http://schemas.microsoft.com/office/powerpoint/2010/main" val="1083574782"/>
       </p:ext>
     </p:extLst>
   </p:cSld>
@@ -3949,7 +3949,7 @@
           <p:cNvPr id="5" name="">
             <a:extLst xmlns:a="http://schemas.openxmlformats.org/drawingml/2006/main">
               <a:ext uri="{FF2B5EF4-FFF2-40B4-BE49-F238E27FC236}">
-                <a16:creationId xmlns:a16="http://schemas.microsoft.com/office/drawing/2014/main" id="{6E76463F-DECD-44CB-9162-6538802E16B7}"/>
+                <a16:creationId xmlns:a16="http://schemas.microsoft.com/office/drawing/2014/main" id="{B2EED7AC-B91A-40EA-BD9B-96ACA3EC0B30}"/>
               </a:ext>
             </a:extLst>
           </p:cNvPr>
@@ -4015,7 +4015,7 @@
           <p:cNvPr id="2" name="">
             <a:extLst xmlns:a="http://schemas.openxmlformats.org/drawingml/2006/main">
               <a:ext uri="{FF2B5EF4-FFF2-40B4-BE49-F238E27FC236}">
-                <a16:creationId xmlns:a16="http://schemas.microsoft.com/office/drawing/2014/main" id="{FA2583B2-D14C-4265-B76F-FA2BC3C78D39}"/>
+                <a16:creationId xmlns:a16="http://schemas.microsoft.com/office/drawing/2014/main" id="{D23F32E9-225D-4FE7-A95A-6AC08700AAF4}"/>
               </a:ext>
             </a:extLst>
           </p:cNvPr>
@@ -4414,7 +4414,7 @@
           <p:cNvPr id="3" name="">
             <a:extLst xmlns:a="http://schemas.openxmlformats.org/drawingml/2006/main">
               <a:ext uri="{FF2B5EF4-FFF2-40B4-BE49-F238E27FC236}">
-                <a16:creationId xmlns:a16="http://schemas.microsoft.com/office/drawing/2014/main" id="{090DD2EC-3220-4742-93A9-53F50F8362B9}"/>
+                <a16:creationId xmlns:a16="http://schemas.microsoft.com/office/drawing/2014/main" id="{6FC5EEA6-8024-4D75-A7F8-D80D41AD0247}"/>
               </a:ext>
             </a:extLst>
           </p:cNvPr>
@@ -4480,7 +4480,7 @@
           <p:cNvPr id="4" name="">
             <a:extLst xmlns:a="http://schemas.openxmlformats.org/drawingml/2006/main">
               <a:ext uri="{FF2B5EF4-FFF2-40B4-BE49-F238E27FC236}">
-                <a16:creationId xmlns:a16="http://schemas.microsoft.com/office/drawing/2014/main" id="{B6C2243A-D123-4FC2-B697-5E6A8DD75FD9}"/>
+                <a16:creationId xmlns:a16="http://schemas.microsoft.com/office/drawing/2014/main" id="{6AFC4CB5-9398-4D33-AA89-0DF3785F4C4C}"/>
               </a:ext>
             </a:extLst>
           </p:cNvPr>
@@ -4544,7 +4544,7 @@
     </p:spTree>
     <p:extLst>
       <p:ext uri="{BB962C8B-B14F-4D97-AF65-F5344CB8AC3E}">
-        <p14:creationId xmlns:p14="http://schemas.microsoft.com/office/powerpoint/2010/main" val="827970695"/>
+        <p14:creationId xmlns:p14="http://schemas.microsoft.com/office/powerpoint/2010/main" val="663884232"/>
       </p:ext>
     </p:extLst>
   </p:cSld>
@@ -4575,7 +4575,7 @@
           <p:cNvPr id="17" name="">
             <a:extLst xmlns:a="http://schemas.openxmlformats.org/drawingml/2006/main">
               <a:ext uri="{FF2B5EF4-FFF2-40B4-BE49-F238E27FC236}">
-                <a16:creationId xmlns:a16="http://schemas.microsoft.com/office/drawing/2014/main" id="{E783111E-17C7-4E39-B295-376F7D825739}"/>
+                <a16:creationId xmlns:a16="http://schemas.microsoft.com/office/drawing/2014/main" id="{024D8525-6BE6-405D-BE45-BF05666681C9}"/>
               </a:ext>
             </a:extLst>
           </p:cNvPr>
@@ -4641,7 +4641,7 @@
           <p:cNvPr id="2" name="">
             <a:extLst xmlns:a="http://schemas.openxmlformats.org/drawingml/2006/main">
               <a:ext uri="{FF2B5EF4-FFF2-40B4-BE49-F238E27FC236}">
-                <a16:creationId xmlns:a16="http://schemas.microsoft.com/office/drawing/2014/main" id="{162748BB-4F24-452F-B071-04B5164D69EC}"/>
+                <a16:creationId xmlns:a16="http://schemas.microsoft.com/office/drawing/2014/main" id="{F48D4F6D-8945-4AD6-8B42-81C4C958AD8E}"/>
               </a:ext>
             </a:extLst>
           </p:cNvPr>
@@ -4707,7 +4707,7 @@
           <p:cNvPr id="3" name="">
             <a:extLst xmlns:a="http://schemas.openxmlformats.org/drawingml/2006/main">
               <a:ext uri="{FF2B5EF4-FFF2-40B4-BE49-F238E27FC236}">
-                <a16:creationId xmlns:a16="http://schemas.microsoft.com/office/drawing/2014/main" id="{43CCBE0C-8F03-485C-A129-E5FEBBCF9F46}"/>
+                <a16:creationId xmlns:a16="http://schemas.microsoft.com/office/drawing/2014/main" id="{4DA96011-26D9-4339-8AEC-E4E8EE4A115F}"/>
               </a:ext>
             </a:extLst>
           </p:cNvPr>
@@ -4773,7 +4773,7 @@
           <p:cNvPr id="4" name="">
             <a:extLst xmlns:a="http://schemas.openxmlformats.org/drawingml/2006/main">
               <a:ext uri="{FF2B5EF4-FFF2-40B4-BE49-F238E27FC236}">
-                <a16:creationId xmlns:a16="http://schemas.microsoft.com/office/drawing/2014/main" id="{DA063ADB-E00C-4CED-ABA5-46DE2A1E1650}"/>
+                <a16:creationId xmlns:a16="http://schemas.microsoft.com/office/drawing/2014/main" id="{48CA58A5-20D2-4E91-8230-D6E576528735}"/>
               </a:ext>
             </a:extLst>
           </p:cNvPr>
@@ -4839,7 +4839,7 @@
           <p:cNvPr id="5" name="">
             <a:extLst xmlns:a="http://schemas.openxmlformats.org/drawingml/2006/main">
               <a:ext uri="{FF2B5EF4-FFF2-40B4-BE49-F238E27FC236}">
-                <a16:creationId xmlns:a16="http://schemas.microsoft.com/office/drawing/2014/main" id="{66145796-860D-4404-BD2E-3B9F1D76520B}"/>
+                <a16:creationId xmlns:a16="http://schemas.microsoft.com/office/drawing/2014/main" id="{8FB1280D-C191-42CC-9492-62340BBAC8D5}"/>
               </a:ext>
             </a:extLst>
           </p:cNvPr>
@@ -4905,7 +4905,7 @@
           <p:cNvPr id="6" name="">
             <a:extLst xmlns:a="http://schemas.openxmlformats.org/drawingml/2006/main">
               <a:ext uri="{FF2B5EF4-FFF2-40B4-BE49-F238E27FC236}">
-                <a16:creationId xmlns:a16="http://schemas.microsoft.com/office/drawing/2014/main" id="{9A6414FC-BE07-4582-8C36-A9191612D404}"/>
+                <a16:creationId xmlns:a16="http://schemas.microsoft.com/office/drawing/2014/main" id="{51BC2986-9F93-4F96-8A37-E0A560057068}"/>
               </a:ext>
             </a:extLst>
           </p:cNvPr>
@@ -4971,7 +4971,7 @@
           <p:cNvPr id="7" name="">
             <a:extLst xmlns:a="http://schemas.openxmlformats.org/drawingml/2006/main">
               <a:ext uri="{FF2B5EF4-FFF2-40B4-BE49-F238E27FC236}">
-                <a16:creationId xmlns:a16="http://schemas.microsoft.com/office/drawing/2014/main" id="{3B0B6647-04E9-468E-AD42-133B1B825B39}"/>
+                <a16:creationId xmlns:a16="http://schemas.microsoft.com/office/drawing/2014/main" id="{23C7ABE8-85F3-444D-8E4D-D0777B08DE52}"/>
               </a:ext>
             </a:extLst>
           </p:cNvPr>
@@ -5037,7 +5037,7 @@
           <p:cNvPr id="8" name="">
             <a:extLst xmlns:a="http://schemas.openxmlformats.org/drawingml/2006/main">
               <a:ext uri="{FF2B5EF4-FFF2-40B4-BE49-F238E27FC236}">
-                <a16:creationId xmlns:a16="http://schemas.microsoft.com/office/drawing/2014/main" id="{146EF876-7F6E-468E-9734-9D7603F8067A}"/>
+                <a16:creationId xmlns:a16="http://schemas.microsoft.com/office/drawing/2014/main" id="{A172B693-A8E6-4C35-B147-0D799FF193F1}"/>
               </a:ext>
             </a:extLst>
           </p:cNvPr>
@@ -5103,7 +5103,7 @@
           <p:cNvPr id="9" name="">
             <a:extLst xmlns:a="http://schemas.openxmlformats.org/drawingml/2006/main">
               <a:ext uri="{FF2B5EF4-FFF2-40B4-BE49-F238E27FC236}">
-                <a16:creationId xmlns:a16="http://schemas.microsoft.com/office/drawing/2014/main" id="{96514A20-5D5E-498E-94B4-A9202F787573}"/>
+                <a16:creationId xmlns:a16="http://schemas.microsoft.com/office/drawing/2014/main" id="{2321E694-D9A8-4152-A0BC-1A465EC9E3FB}"/>
               </a:ext>
             </a:extLst>
           </p:cNvPr>
@@ -5169,7 +5169,7 @@
           <p:cNvPr id="10" name="">
             <a:extLst xmlns:a="http://schemas.openxmlformats.org/drawingml/2006/main">
               <a:ext uri="{FF2B5EF4-FFF2-40B4-BE49-F238E27FC236}">
-                <a16:creationId xmlns:a16="http://schemas.microsoft.com/office/drawing/2014/main" id="{71388845-4556-4E8E-98B1-E40A19E872B8}"/>
+                <a16:creationId xmlns:a16="http://schemas.microsoft.com/office/drawing/2014/main" id="{C88A9A70-0848-40B0-885C-0E5D1B550D59}"/>
               </a:ext>
             </a:extLst>
           </p:cNvPr>
@@ -5235,7 +5235,7 @@
           <p:cNvPr id="11" name="">
             <a:extLst xmlns:a="http://schemas.openxmlformats.org/drawingml/2006/main">
               <a:ext uri="{FF2B5EF4-FFF2-40B4-BE49-F238E27FC236}">
-                <a16:creationId xmlns:a16="http://schemas.microsoft.com/office/drawing/2014/main" id="{7CE88805-AC94-44D3-ADC9-59EEEE16D606}"/>
+                <a16:creationId xmlns:a16="http://schemas.microsoft.com/office/drawing/2014/main" id="{5DE0171F-7E40-4C66-B5BF-E6EA122E2F58}"/>
               </a:ext>
             </a:extLst>
           </p:cNvPr>
@@ -5301,7 +5301,7 @@
           <p:cNvPr id="12" name="">
             <a:extLst xmlns:a="http://schemas.openxmlformats.org/drawingml/2006/main">
               <a:ext uri="{FF2B5EF4-FFF2-40B4-BE49-F238E27FC236}">
-                <a16:creationId xmlns:a16="http://schemas.microsoft.com/office/drawing/2014/main" id="{02A330B2-F01E-41BF-AAEE-FCF0ACF69A40}"/>
+                <a16:creationId xmlns:a16="http://schemas.microsoft.com/office/drawing/2014/main" id="{357C1226-C6C5-4583-8DDA-B03A7D5C3410}"/>
               </a:ext>
             </a:extLst>
           </p:cNvPr>
@@ -5367,7 +5367,7 @@
           <p:cNvPr id="13" name="">
             <a:extLst xmlns:a="http://schemas.openxmlformats.org/drawingml/2006/main">
               <a:ext uri="{FF2B5EF4-FFF2-40B4-BE49-F238E27FC236}">
-                <a16:creationId xmlns:a16="http://schemas.microsoft.com/office/drawing/2014/main" id="{1889EFD9-1EEC-4B8E-8172-C494635E75D9}"/>
+                <a16:creationId xmlns:a16="http://schemas.microsoft.com/office/drawing/2014/main" id="{E0E4DDED-6C4E-4B72-807A-21282881AEEC}"/>
               </a:ext>
             </a:extLst>
           </p:cNvPr>
@@ -5433,7 +5433,7 @@
           <p:cNvPr id="14" name="">
             <a:extLst xmlns:a="http://schemas.openxmlformats.org/drawingml/2006/main">
               <a:ext uri="{FF2B5EF4-FFF2-40B4-BE49-F238E27FC236}">
-                <a16:creationId xmlns:a16="http://schemas.microsoft.com/office/drawing/2014/main" id="{1D648927-707F-492D-B4F0-CCCB6F105A6B}"/>
+                <a16:creationId xmlns:a16="http://schemas.microsoft.com/office/drawing/2014/main" id="{DC991D0C-28F8-4D08-B3BE-6C5DBF281A72}"/>
               </a:ext>
             </a:extLst>
           </p:cNvPr>
@@ -5499,7 +5499,7 @@
           <p:cNvPr id="15" name="">
             <a:extLst xmlns:a="http://schemas.openxmlformats.org/drawingml/2006/main">
               <a:ext uri="{FF2B5EF4-FFF2-40B4-BE49-F238E27FC236}">
-                <a16:creationId xmlns:a16="http://schemas.microsoft.com/office/drawing/2014/main" id="{25826807-FE2B-4285-BBD1-757B19CB9CEA}"/>
+                <a16:creationId xmlns:a16="http://schemas.microsoft.com/office/drawing/2014/main" id="{6B8213F0-A91A-4982-8D63-6E61C227B2D8}"/>
               </a:ext>
             </a:extLst>
           </p:cNvPr>
@@ -5565,7 +5565,7 @@
           <p:cNvPr id="16" name="">
             <a:extLst xmlns:a="http://schemas.openxmlformats.org/drawingml/2006/main">
               <a:ext uri="{FF2B5EF4-FFF2-40B4-BE49-F238E27FC236}">
-                <a16:creationId xmlns:a16="http://schemas.microsoft.com/office/drawing/2014/main" id="{D6D8EC76-2379-4AD1-8EA4-6D6D7433347C}"/>
+                <a16:creationId xmlns:a16="http://schemas.microsoft.com/office/drawing/2014/main" id="{ABA6A3F9-B930-4E66-BDED-63BBCE81067A}"/>
               </a:ext>
             </a:extLst>
           </p:cNvPr>
@@ -5629,7 +5629,7 @@
     </p:spTree>
     <p:extLst>
       <p:ext uri="{BB962C8B-B14F-4D97-AF65-F5344CB8AC3E}">
-        <p14:creationId xmlns:p14="http://schemas.microsoft.com/office/powerpoint/2010/main" val="354994264"/>
+        <p14:creationId xmlns:p14="http://schemas.microsoft.com/office/powerpoint/2010/main" val="1598297711"/>
       </p:ext>
     </p:extLst>
   </p:cSld>
@@ -5660,7 +5660,7 @@
           <p:cNvPr id="3" name="">
             <a:extLst xmlns:a="http://schemas.openxmlformats.org/drawingml/2006/main">
               <a:ext uri="{FF2B5EF4-FFF2-40B4-BE49-F238E27FC236}">
-                <a16:creationId xmlns:a16="http://schemas.microsoft.com/office/drawing/2014/main" id="{C545191E-6F38-426F-9B7B-60C592C7C15B}"/>
+                <a16:creationId xmlns:a16="http://schemas.microsoft.com/office/drawing/2014/main" id="{E4A88F41-10BA-456E-AC59-0AB6FC42616E}"/>
               </a:ext>
             </a:extLst>
           </p:cNvPr>
@@ -5726,7 +5726,7 @@
           <p:cNvPr id="2" name="">
             <a:extLst xmlns:a="http://schemas.openxmlformats.org/drawingml/2006/main">
               <a:ext uri="{FF2B5EF4-FFF2-40B4-BE49-F238E27FC236}">
-                <a16:creationId xmlns:a16="http://schemas.microsoft.com/office/drawing/2014/main" id="{F527330F-EB69-46E9-9EAB-3DCE0893225B}"/>
+                <a16:creationId xmlns:a16="http://schemas.microsoft.com/office/drawing/2014/main" id="{E560D27C-03F1-4D3A-AA8F-5D6DAD0964BE}"/>
               </a:ext>
             </a:extLst>
           </p:cNvPr>
@@ -5736,7 +5736,7 @@
           <p:nvPr/>
         </p:nvPicPr>
         <p:blipFill>
-          <a:blip xmlns:r="http://schemas.openxmlformats.org/officeDocument/2006/relationships" xmlns:a="http://schemas.openxmlformats.org/drawingml/2006/main" r:embed="R460194326e624ff3"/>
+          <a:blip xmlns:r="http://schemas.openxmlformats.org/officeDocument/2006/relationships" xmlns:a="http://schemas.openxmlformats.org/drawingml/2006/main" r:embed="R1358776e38c24f31"/>
           <a:stretch xmlns:a="http://schemas.openxmlformats.org/drawingml/2006/main"/>
         </p:blipFill>
         <p:spPr>
@@ -5752,7 +5752,7 @@
     </p:spTree>
     <p:extLst>
       <p:ext uri="{BB962C8B-B14F-4D97-AF65-F5344CB8AC3E}">
-        <p14:creationId xmlns:p14="http://schemas.microsoft.com/office/powerpoint/2010/main" val="1074485192"/>
+        <p14:creationId xmlns:p14="http://schemas.microsoft.com/office/powerpoint/2010/main" val="124613631"/>
       </p:ext>
     </p:extLst>
   </p:cSld>
@@ -5783,7 +5783,7 @@
           <p:cNvPr id="7" name="">
             <a:extLst xmlns:a="http://schemas.openxmlformats.org/drawingml/2006/main">
               <a:ext uri="{FF2B5EF4-FFF2-40B4-BE49-F238E27FC236}">
-                <a16:creationId xmlns:a16="http://schemas.microsoft.com/office/drawing/2014/main" id="{C16AD6C7-E116-463D-A093-DDC9649333A8}"/>
+                <a16:creationId xmlns:a16="http://schemas.microsoft.com/office/drawing/2014/main" id="{74314070-2772-4BB9-A1E8-F4EE0E09D88B}"/>
               </a:ext>
             </a:extLst>
           </p:cNvPr>
@@ -5849,7 +5849,7 @@
           <p:cNvPr id="2" name="">
             <a:extLst xmlns:a="http://schemas.openxmlformats.org/drawingml/2006/main">
               <a:ext uri="{FF2B5EF4-FFF2-40B4-BE49-F238E27FC236}">
-                <a16:creationId xmlns:a16="http://schemas.microsoft.com/office/drawing/2014/main" id="{1645340B-CABD-4D64-BF88-30836E91785F}"/>
+                <a16:creationId xmlns:a16="http://schemas.microsoft.com/office/drawing/2014/main" id="{89FDD1C4-5F50-45E3-B3AB-ACEE12281662}"/>
               </a:ext>
             </a:extLst>
           </p:cNvPr>
@@ -5915,7 +5915,7 @@
           <p:cNvPr id="3" name="">
             <a:extLst xmlns:a="http://schemas.openxmlformats.org/drawingml/2006/main">
               <a:ext uri="{FF2B5EF4-FFF2-40B4-BE49-F238E27FC236}">
-                <a16:creationId xmlns:a16="http://schemas.microsoft.com/office/drawing/2014/main" id="{52D61CAE-0E2A-40F7-868F-C1F6BF5B3C0F}"/>
+                <a16:creationId xmlns:a16="http://schemas.microsoft.com/office/drawing/2014/main" id="{C2D7A647-C7CD-4703-AC0D-C758279F7B29}"/>
               </a:ext>
             </a:extLst>
           </p:cNvPr>
@@ -6119,7 +6119,7 @@
           <p:cNvPr id="4" name="">
             <a:extLst xmlns:a="http://schemas.openxmlformats.org/drawingml/2006/main">
               <a:ext uri="{FF2B5EF4-FFF2-40B4-BE49-F238E27FC236}">
-                <a16:creationId xmlns:a16="http://schemas.microsoft.com/office/drawing/2014/main" id="{8A0FFCD9-9204-4D99-B4B8-3E4C3A8A15E5}"/>
+                <a16:creationId xmlns:a16="http://schemas.microsoft.com/office/drawing/2014/main" id="{B7B822A3-2484-4230-BB29-2B432D1EF95E}"/>
               </a:ext>
             </a:extLst>
           </p:cNvPr>
@@ -6185,7 +6185,7 @@
           <p:cNvPr id="5" name="">
             <a:extLst xmlns:a="http://schemas.openxmlformats.org/drawingml/2006/main">
               <a:ext uri="{FF2B5EF4-FFF2-40B4-BE49-F238E27FC236}">
-                <a16:creationId xmlns:a16="http://schemas.microsoft.com/office/drawing/2014/main" id="{5D6EE0C8-702D-4A3F-8EEC-27518A8AAC09}"/>
+                <a16:creationId xmlns:a16="http://schemas.microsoft.com/office/drawing/2014/main" id="{72E698F8-3BD5-4996-B29C-DF8BBA8257E1}"/>
               </a:ext>
             </a:extLst>
           </p:cNvPr>
@@ -6389,7 +6389,7 @@
           <p:cNvPr id="6" name="">
             <a:extLst xmlns:a="http://schemas.openxmlformats.org/drawingml/2006/main">
               <a:ext uri="{FF2B5EF4-FFF2-40B4-BE49-F238E27FC236}">
-                <a16:creationId xmlns:a16="http://schemas.microsoft.com/office/drawing/2014/main" id="{AC519F27-099F-42FE-A9A3-B4D467CD9DBB}"/>
+                <a16:creationId xmlns:a16="http://schemas.microsoft.com/office/drawing/2014/main" id="{14A55925-A19E-4FCD-9226-8B1739C6E7F6}"/>
               </a:ext>
             </a:extLst>
           </p:cNvPr>
@@ -6453,7 +6453,7 @@
     </p:spTree>
     <p:extLst>
       <p:ext uri="{BB962C8B-B14F-4D97-AF65-F5344CB8AC3E}">
-        <p14:creationId xmlns:p14="http://schemas.microsoft.com/office/powerpoint/2010/main" val="1749153145"/>
+        <p14:creationId xmlns:p14="http://schemas.microsoft.com/office/powerpoint/2010/main" val="1488048"/>
       </p:ext>
     </p:extLst>
   </p:cSld>
@@ -6484,7 +6484,7 @@
           <p:cNvPr id="6" name="">
             <a:extLst xmlns:a="http://schemas.openxmlformats.org/drawingml/2006/main">
               <a:ext uri="{FF2B5EF4-FFF2-40B4-BE49-F238E27FC236}">
-                <a16:creationId xmlns:a16="http://schemas.microsoft.com/office/drawing/2014/main" id="{81E5A6F2-2311-4DDF-B5DB-821FD24B3830}"/>
+                <a16:creationId xmlns:a16="http://schemas.microsoft.com/office/drawing/2014/main" id="{20B0C3F0-2026-487A-AA58-A30D3DB17CB1}"/>
               </a:ext>
             </a:extLst>
           </p:cNvPr>
@@ -6550,7 +6550,7 @@
           <p:cNvPr id="2" name="">
             <a:extLst xmlns:a="http://schemas.openxmlformats.org/drawingml/2006/main">
               <a:ext uri="{FF2B5EF4-FFF2-40B4-BE49-F238E27FC236}">
-                <a16:creationId xmlns:a16="http://schemas.microsoft.com/office/drawing/2014/main" id="{2D430EE4-7507-461C-843F-9CE9742334E4}"/>
+                <a16:creationId xmlns:a16="http://schemas.microsoft.com/office/drawing/2014/main" id="{5B24E988-120E-48AA-9894-52C9A82320A1}"/>
               </a:ext>
             </a:extLst>
           </p:cNvPr>
@@ -6616,7 +6616,7 @@
           <p:cNvPr id="3" name="">
             <a:extLst xmlns:a="http://schemas.openxmlformats.org/drawingml/2006/main">
               <a:ext uri="{FF2B5EF4-FFF2-40B4-BE49-F238E27FC236}">
-                <a16:creationId xmlns:a16="http://schemas.microsoft.com/office/drawing/2014/main" id="{BC579709-0D2C-4019-BC53-CCD9F67E5CE3}"/>
+                <a16:creationId xmlns:a16="http://schemas.microsoft.com/office/drawing/2014/main" id="{7F1118E3-2FC1-40BD-8280-C7F97FD98C0A}"/>
               </a:ext>
             </a:extLst>
           </p:cNvPr>
@@ -6682,7 +6682,7 @@
           <p:cNvPr id="4" name="">
             <a:extLst xmlns:a="http://schemas.openxmlformats.org/drawingml/2006/main">
               <a:ext uri="{FF2B5EF4-FFF2-40B4-BE49-F238E27FC236}">
-                <a16:creationId xmlns:a16="http://schemas.microsoft.com/office/drawing/2014/main" id="{551B2818-1F40-47B3-A420-EB5CFABC20A3}"/>
+                <a16:creationId xmlns:a16="http://schemas.microsoft.com/office/drawing/2014/main" id="{29CB4C7C-BDF6-4CBD-8C85-60E53578EFCC}"/>
               </a:ext>
             </a:extLst>
           </p:cNvPr>
@@ -6771,7 +6771,7 @@
           <p:cNvPr id="5" name="">
             <a:extLst xmlns:a="http://schemas.openxmlformats.org/drawingml/2006/main">
               <a:ext uri="{FF2B5EF4-FFF2-40B4-BE49-F238E27FC236}">
-                <a16:creationId xmlns:a16="http://schemas.microsoft.com/office/drawing/2014/main" id="{80BB520A-9D9C-4BD1-934E-836A29FB6196}"/>
+                <a16:creationId xmlns:a16="http://schemas.microsoft.com/office/drawing/2014/main" id="{1B56C86A-226D-4A50-90F9-74A1A69AC870}"/>
               </a:ext>
             </a:extLst>
           </p:cNvPr>
@@ -6835,7 +6835,7 @@
     </p:spTree>
     <p:extLst>
       <p:ext uri="{BB962C8B-B14F-4D97-AF65-F5344CB8AC3E}">
-        <p14:creationId xmlns:p14="http://schemas.microsoft.com/office/powerpoint/2010/main" val="914870845"/>
+        <p14:creationId xmlns:p14="http://schemas.microsoft.com/office/powerpoint/2010/main" val="1615698893"/>
       </p:ext>
     </p:extLst>
   </p:cSld>
@@ -6866,7 +6866,7 @@
           <p:cNvPr id="8" name="">
             <a:extLst xmlns:a="http://schemas.openxmlformats.org/drawingml/2006/main">
               <a:ext uri="{FF2B5EF4-FFF2-40B4-BE49-F238E27FC236}">
-                <a16:creationId xmlns:a16="http://schemas.microsoft.com/office/drawing/2014/main" id="{4B2FB086-3747-4924-8DB9-04BB6E21015D}"/>
+                <a16:creationId xmlns:a16="http://schemas.microsoft.com/office/drawing/2014/main" id="{2D77DE10-09D4-4C89-929E-FC59BD8CC044}"/>
               </a:ext>
             </a:extLst>
           </p:cNvPr>
@@ -6932,7 +6932,7 @@
           <p:cNvPr id="2" name="">
             <a:extLst xmlns:a="http://schemas.openxmlformats.org/drawingml/2006/main">
               <a:ext uri="{FF2B5EF4-FFF2-40B4-BE49-F238E27FC236}">
-                <a16:creationId xmlns:a16="http://schemas.microsoft.com/office/drawing/2014/main" id="{DABF9394-5A2D-43AA-8DEC-FFB56C8EBC36}"/>
+                <a16:creationId xmlns:a16="http://schemas.microsoft.com/office/drawing/2014/main" id="{09A2C571-B7C8-41EC-A052-FA6A4B853FBA}"/>
               </a:ext>
             </a:extLst>
           </p:cNvPr>
@@ -6998,7 +6998,7 @@
           <p:cNvPr id="3" name="">
             <a:extLst xmlns:a="http://schemas.openxmlformats.org/drawingml/2006/main">
               <a:ext uri="{FF2B5EF4-FFF2-40B4-BE49-F238E27FC236}">
-                <a16:creationId xmlns:a16="http://schemas.microsoft.com/office/drawing/2014/main" id="{770DAED8-928A-4147-9B98-EB8A49CD55A5}"/>
+                <a16:creationId xmlns:a16="http://schemas.microsoft.com/office/drawing/2014/main" id="{2A3D2014-1C75-4BC5-AA54-967F7E7EC9CA}"/>
               </a:ext>
             </a:extLst>
           </p:cNvPr>
@@ -7064,7 +7064,7 @@
           <p:cNvPr id="4" name="">
             <a:extLst xmlns:a="http://schemas.openxmlformats.org/drawingml/2006/main">
               <a:ext uri="{FF2B5EF4-FFF2-40B4-BE49-F238E27FC236}">
-                <a16:creationId xmlns:a16="http://schemas.microsoft.com/office/drawing/2014/main" id="{2875A4AA-20FC-42C9-B5AD-8D78CADE7A4D}"/>
+                <a16:creationId xmlns:a16="http://schemas.microsoft.com/office/drawing/2014/main" id="{74166A45-BFFC-41BC-8758-35D942A2815C}"/>
               </a:ext>
             </a:extLst>
           </p:cNvPr>
@@ -7176,7 +7176,7 @@
           <p:cNvPr id="5" name="">
             <a:extLst xmlns:a="http://schemas.openxmlformats.org/drawingml/2006/main">
               <a:ext uri="{FF2B5EF4-FFF2-40B4-BE49-F238E27FC236}">
-                <a16:creationId xmlns:a16="http://schemas.microsoft.com/office/drawing/2014/main" id="{E22758DA-07CB-4D32-9D83-B9F729ED7FC9}"/>
+                <a16:creationId xmlns:a16="http://schemas.microsoft.com/office/drawing/2014/main" id="{EEFD8CDA-BB09-4F09-A57F-FFD4327BE366}"/>
               </a:ext>
             </a:extLst>
           </p:cNvPr>
@@ -7242,7 +7242,7 @@
           <p:cNvPr id="6" name="">
             <a:extLst xmlns:a="http://schemas.openxmlformats.org/drawingml/2006/main">
               <a:ext uri="{FF2B5EF4-FFF2-40B4-BE49-F238E27FC236}">
-                <a16:creationId xmlns:a16="http://schemas.microsoft.com/office/drawing/2014/main" id="{259448CA-F27B-4DEB-9ABF-6DF8AF9FC516}"/>
+                <a16:creationId xmlns:a16="http://schemas.microsoft.com/office/drawing/2014/main" id="{88910E2C-F943-45DE-86C3-DE145D2A02C2}"/>
               </a:ext>
             </a:extLst>
           </p:cNvPr>
@@ -7364,7 +7364,7 @@
           <p:cNvPr id="7" name="">
             <a:extLst xmlns:a="http://schemas.openxmlformats.org/drawingml/2006/main">
               <a:ext uri="{FF2B5EF4-FFF2-40B4-BE49-F238E27FC236}">
-                <a16:creationId xmlns:a16="http://schemas.microsoft.com/office/drawing/2014/main" id="{EF900CD6-CE9C-4439-902B-8849FDB2C24D}"/>
+                <a16:creationId xmlns:a16="http://schemas.microsoft.com/office/drawing/2014/main" id="{E6866696-A730-4A9C-BE39-EDDED0CEF5DA}"/>
               </a:ext>
             </a:extLst>
           </p:cNvPr>
@@ -7428,7 +7428,7 @@
     </p:spTree>
     <p:extLst>
       <p:ext uri="{BB962C8B-B14F-4D97-AF65-F5344CB8AC3E}">
-        <p14:creationId xmlns:p14="http://schemas.microsoft.com/office/powerpoint/2010/main" val="994696394"/>
+        <p14:creationId xmlns:p14="http://schemas.microsoft.com/office/powerpoint/2010/main" val="61914311"/>
       </p:ext>
     </p:extLst>
   </p:cSld>
@@ -7459,7 +7459,7 @@
           <p:cNvPr id="6" name="">
             <a:extLst xmlns:a="http://schemas.openxmlformats.org/drawingml/2006/main">
               <a:ext uri="{FF2B5EF4-FFF2-40B4-BE49-F238E27FC236}">
-                <a16:creationId xmlns:a16="http://schemas.microsoft.com/office/drawing/2014/main" id="{4522E255-6EC4-4741-9D49-D29365B45E14}"/>
+                <a16:creationId xmlns:a16="http://schemas.microsoft.com/office/drawing/2014/main" id="{713BCD51-1717-48EB-B924-8D2CE345759E}"/>
               </a:ext>
             </a:extLst>
           </p:cNvPr>
@@ -7525,7 +7525,7 @@
           <p:cNvPr id="2" name="">
             <a:extLst xmlns:a="http://schemas.openxmlformats.org/drawingml/2006/main">
               <a:ext uri="{FF2B5EF4-FFF2-40B4-BE49-F238E27FC236}">
-                <a16:creationId xmlns:a16="http://schemas.microsoft.com/office/drawing/2014/main" id="{7AA116CC-4EC9-4391-8179-9B8811822319}"/>
+                <a16:creationId xmlns:a16="http://schemas.microsoft.com/office/drawing/2014/main" id="{309262A8-1D45-466B-BC00-CDE4A1A50255}"/>
               </a:ext>
             </a:extLst>
           </p:cNvPr>
@@ -7591,7 +7591,7 @@
           <p:cNvPr id="3" name="">
             <a:extLst xmlns:a="http://schemas.openxmlformats.org/drawingml/2006/main">
               <a:ext uri="{FF2B5EF4-FFF2-40B4-BE49-F238E27FC236}">
-                <a16:creationId xmlns:a16="http://schemas.microsoft.com/office/drawing/2014/main" id="{082ED2EC-87CD-4552-A142-210CDB906554}"/>
+                <a16:creationId xmlns:a16="http://schemas.microsoft.com/office/drawing/2014/main" id="{1019C4D8-AA54-443D-B812-8C42AB6DBA35}"/>
               </a:ext>
             </a:extLst>
           </p:cNvPr>
@@ -7647,7 +7647,7 @@
                 <a:ea typeface="Arial"/>
                 <a:cs typeface="Arial"/>
               </a:rPr>
-              <a:t>33 backend tests + 3 component tests passed</a:t>
+              <a:t>33 backend + 3 component + 4 browser tests passed</a:t>
             </a:r>
           </a:p>
           <a:p xmlns:a="http://schemas.openxmlformats.org/drawingml/2006/main">
@@ -7693,7 +7693,7 @@
                 <a:ea typeface="Arial"/>
                 <a:cs typeface="Arial"/>
               </a:rPr>
-              <a:t>Approval, rejection and persistence checked in browser</a:t>
+              <a:t>Replit approval and reload persistence verified</a:t>
             </a:r>
           </a:p>
         </p:txBody>
@@ -7703,7 +7703,7 @@
           <p:cNvPr id="4" name="">
             <a:extLst xmlns:a="http://schemas.openxmlformats.org/drawingml/2006/main">
               <a:ext uri="{FF2B5EF4-FFF2-40B4-BE49-F238E27FC236}">
-                <a16:creationId xmlns:a16="http://schemas.microsoft.com/office/drawing/2014/main" id="{0157AAB5-A5D2-45C1-AC5E-3EF4FA8CB171}"/>
+                <a16:creationId xmlns:a16="http://schemas.microsoft.com/office/drawing/2014/main" id="{C27D7585-1DFE-46BB-95F5-69D37FA7C7BE}"/>
               </a:ext>
             </a:extLst>
           </p:cNvPr>
@@ -7769,7 +7769,7 @@
           <p:cNvPr id="5" name="">
             <a:extLst xmlns:a="http://schemas.openxmlformats.org/drawingml/2006/main">
               <a:ext uri="{FF2B5EF4-FFF2-40B4-BE49-F238E27FC236}">
-                <a16:creationId xmlns:a16="http://schemas.microsoft.com/office/drawing/2014/main" id="{85C7CB87-BB96-4655-9BEE-0AC2AB4DC90F}"/>
+                <a16:creationId xmlns:a16="http://schemas.microsoft.com/office/drawing/2014/main" id="{8A79FB6D-E498-4EBF-AEC0-4FCE35947AC4}"/>
               </a:ext>
             </a:extLst>
           </p:cNvPr>
@@ -7825,7 +7825,7 @@
                 <a:ea typeface="Arial"/>
                 <a:cs typeface="Arial"/>
               </a:rPr>
-              <a:t>Playwright in compatible CI · genuine Replit use</a:t>
+              <a:t>GitHub CI and publication · team review</a:t>
             </a:r>
           </a:p>
           <a:p xmlns:a="http://schemas.openxmlformats.org/drawingml/2006/main">
@@ -7856,7 +7856,7 @@
     </p:spTree>
     <p:extLst>
       <p:ext uri="{BB962C8B-B14F-4D97-AF65-F5344CB8AC3E}">
-        <p14:creationId xmlns:p14="http://schemas.microsoft.com/office/powerpoint/2010/main" val="230130688"/>
+        <p14:creationId xmlns:p14="http://schemas.microsoft.com/office/powerpoint/2010/main" val="2006376487"/>
       </p:ext>
     </p:extLst>
   </p:cSld>

</xml_diff>